<commit_message>
Surface the live links, and add a licence
The repository is being submitted as the code deliverable, so a reviewer should
be able to see what it does before reading any of it. The README now opens with
the running application, the API, and the two demo accounts, with a line on what
to click to see the role projection - the thing that is hard to explain and
obvious to look at.

The deck carries both links three times: on the cover, on a slide of their own
near the end, and on the closing slide. A deck that quotes measurements is worth
more when the reader can go and check them.

Also an MIT licence, and a repository description and homepage so the GitHub
page states what this is without anyone opening a file.

Co-Authored-By: Claude Opus 5 <noreply@anthropic.com>
</commit_message>
<xml_diff>
--- a/docs/Pratyaya-Synchrony-Hackathon.pptx
+++ b/docs/Pratyaya-Synchrony-Hackathon.pptx
@@ -37,9 +37,10 @@
     <p:sldId id="285" r:id="rId31"/>
     <p:sldId id="286" r:id="rId32"/>
     <p:sldId id="287" r:id="rId33"/>
+    <p:sldId id="288" r:id="rId34"/>
   </p:sldIdLst>
   <p:notesMasterIdLst>
-    <p:notesMasterId r:id="rId34"/>
+    <p:notesMasterId r:id="rId35"/>
   </p:notesMasterIdLst>
   <p:sldSz cx="12192000" cy="6858000"/>
   <p:notesSz cx="6858000" cy="12192000"/>
@@ -2733,7 +2734,7 @@
           <a:p>
             <a:r>
               <a:rPr lang="en-US" dirty="0"/>
-              <a:t>Close on the three chips. They are the promise of the system in nine words.</a:t>
+              <a:t>Read both links out. This is the slide that turns a deck into something they can verify for themselves in the room.</a:t>
             </a:r>
             <a:endParaRPr lang="en-US" dirty="0"/>
           </a:p>
@@ -2757,6 +2758,94 @@
             <a:fld id="{F7021451-1387-4CA6-816F-3879F97B5CBC}" type="slidenum">
               <a:rPr lang="en-US"/>
               <a:t>32</a:t>
+            </a:fld>
+            <a:endParaRPr lang="en-US"/>
+          </a:p>
+        </p:txBody>
+      </p:sp>
+    </p:spTree>
+    <p:extLst>
+      <p:ext uri="{BB962C8B-B14F-4D97-AF65-F5344CB8AC3E}">
+        <p14:creationId xmlns:p14="http://schemas.microsoft.com/office/powerpoint/2010/main" val="1024086991"/>
+      </p:ext>
+    </p:extLst>
+  </p:cSld>
+  <p:clrMapOvr>
+    <a:masterClrMapping/>
+  </p:clrMapOvr>
+</p:notes>
+</file>
+
+<file path=ppt/notesSlides/notesSlide33.xml><?xml version="1.0" encoding="utf-8"?>
+<p:notes xmlns:a="http://schemas.openxmlformats.org/drawingml/2006/main" xmlns:r="http://schemas.openxmlformats.org/officeDocument/2006/relationships" xmlns:p="http://schemas.openxmlformats.org/presentationml/2006/main">
+  <p:cSld>
+    <p:spTree>
+      <p:nvGrpSpPr>
+        <p:cNvPr id="1" name=""/>
+        <p:cNvGrpSpPr/>
+        <p:nvPr/>
+      </p:nvGrpSpPr>
+      <p:grpSpPr>
+        <a:xfrm>
+          <a:off x="0" y="0"/>
+          <a:ext cx="0" cy="0"/>
+          <a:chOff x="0" y="0"/>
+          <a:chExt cx="0" cy="0"/>
+        </a:xfrm>
+      </p:grpSpPr>
+      <p:sp>
+        <p:nvSpPr>
+          <p:cNvPr id="2" name="Slide Image Placeholder 1"/>
+          <p:cNvSpPr>
+            <a:spLocks noGrp="1" noRot="1" noChangeAspect="1"/>
+          </p:cNvSpPr>
+          <p:nvPr>
+            <p:ph type="sldImg"/>
+          </p:nvPr>
+        </p:nvSpPr>
+        <p:spPr/>
+      </p:sp>
+      <p:sp>
+        <p:nvSpPr>
+          <p:cNvPr id="3" name="Notes Placeholder 2"/>
+          <p:cNvSpPr>
+            <a:spLocks noGrp="1"/>
+          </p:cNvSpPr>
+          <p:nvPr>
+            <p:ph type="body" idx="1"/>
+          </p:nvPr>
+        </p:nvSpPr>
+        <p:spPr/>
+        <p:txBody>
+          <a:bodyPr/>
+          <a:lstStyle/>
+          <a:p>
+            <a:r>
+              <a:rPr lang="en-US" dirty="0"/>
+              <a:t>Close on the three chips. They are the promise of the system in nine words.</a:t>
+            </a:r>
+            <a:endParaRPr lang="en-US" dirty="0"/>
+          </a:p>
+        </p:txBody>
+      </p:sp>
+      <p:sp>
+        <p:nvSpPr>
+          <p:cNvPr id="4" name="Slide Number Placeholder 3"/>
+          <p:cNvSpPr>
+            <a:spLocks noGrp="1"/>
+          </p:cNvSpPr>
+          <p:nvPr>
+            <p:ph type="sldNum" sz="quarter" idx="10"/>
+          </p:nvPr>
+        </p:nvSpPr>
+        <p:spPr/>
+        <p:txBody>
+          <a:bodyPr/>
+          <a:lstStyle/>
+          <a:p>
+            <a:fld id="{F7021451-1387-4CA6-816F-3879F97B5CBC}" type="slidenum">
+              <a:rPr lang="en-US"/>
+              <a:t>33</a:t>
             </a:fld>
             <a:endParaRPr lang="en-US"/>
           </a:p>
@@ -3762,7 +3851,7 @@
         </p:nvSpPr>
         <p:spPr>
           <a:xfrm>
-            <a:off x="502920" y="3794760"/>
+            <a:off x="502920" y="3858768"/>
             <a:ext cx="2377440" cy="457200"/>
           </a:xfrm>
           <a:prstGeom prst="roundRect">
@@ -3784,7 +3873,7 @@
         </p:nvSpPr>
         <p:spPr>
           <a:xfrm>
-            <a:off x="502920" y="3794760"/>
+            <a:off x="502920" y="3858768"/>
             <a:ext cx="2377440" cy="457200"/>
           </a:xfrm>
           <a:prstGeom prst="rect">
@@ -3823,7 +3912,7 @@
         </p:nvSpPr>
         <p:spPr>
           <a:xfrm>
-            <a:off x="3081528" y="3794760"/>
+            <a:off x="3081528" y="3858768"/>
             <a:ext cx="2377440" cy="457200"/>
           </a:xfrm>
           <a:prstGeom prst="roundRect">
@@ -3845,7 +3934,7 @@
         </p:nvSpPr>
         <p:spPr>
           <a:xfrm>
-            <a:off x="3081528" y="3794760"/>
+            <a:off x="3081528" y="3858768"/>
             <a:ext cx="2377440" cy="457200"/>
           </a:xfrm>
           <a:prstGeom prst="rect">
@@ -3884,7 +3973,7 @@
         </p:nvSpPr>
         <p:spPr>
           <a:xfrm>
-            <a:off x="5660136" y="3794760"/>
+            <a:off x="5660136" y="3858768"/>
             <a:ext cx="2377440" cy="457200"/>
           </a:xfrm>
           <a:prstGeom prst="roundRect">
@@ -3906,7 +3995,7 @@
         </p:nvSpPr>
         <p:spPr>
           <a:xfrm>
-            <a:off x="5660136" y="3794760"/>
+            <a:off x="5660136" y="3858768"/>
             <a:ext cx="2377440" cy="457200"/>
           </a:xfrm>
           <a:prstGeom prst="rect">
@@ -3945,7 +4034,110 @@
         </p:nvSpPr>
         <p:spPr>
           <a:xfrm>
-            <a:off x="502920" y="4892040"/>
+            <a:off x="502920" y="4617720"/>
+            <a:ext cx="11155680" cy="786384"/>
+          </a:xfrm>
+          <a:prstGeom prst="roundRect">
+            <a:avLst>
+              <a:gd name="adj" fmla="val 11628"/>
+            </a:avLst>
+          </a:prstGeom>
+          <a:solidFill>
+            <a:srgbClr val="1C2F3D"/>
+          </a:solidFill>
+          <a:ln/>
+        </p:spPr>
+      </p:sp>
+      <p:sp>
+        <p:nvSpPr>
+          <p:cNvPr id="12" name="Text 10"/>
+          <p:cNvSpPr txBox="1"/>
+          <p:nvPr/>
+        </p:nvSpPr>
+        <p:spPr>
+          <a:xfrm>
+            <a:off x="777240" y="4617720"/>
+            <a:ext cx="10607040" cy="786384"/>
+          </a:xfrm>
+          <a:prstGeom prst="rect">
+            <a:avLst/>
+          </a:prstGeom>
+          <a:noFill/>
+          <a:ln/>
+        </p:spPr>
+        <p:txBody>
+          <a:bodyPr wrap="square" lIns="0" tIns="0" rIns="0" bIns="0" rtlCol="0" anchor="ctr"/>
+          <a:lstStyle/>
+          <a:p>
+            <a:pPr indent="0" marL="0">
+              <a:buNone/>
+            </a:pPr>
+            <a:r>
+              <a:rPr lang="en-US" sz="1100" b="1" spc="150" kern="0" dirty="0">
+                <a:solidFill>
+                  <a:srgbClr val="8FD7B8"/>
+                </a:solidFill>
+                <a:latin typeface="Calibri" pitchFamily="34" charset="0"/>
+                <a:ea typeface="Calibri" pitchFamily="34" charset="-122"/>
+                <a:cs typeface="Calibri" pitchFamily="34" charset="-120"/>
+              </a:rPr>
+              <a:t>LIVE  </a:t>
+            </a:r>
+            <a:pPr indent="0" marL="0">
+              <a:buNone/>
+            </a:pPr>
+            <a:r>
+              <a:rPr lang="en-US" sz="1500" b="1" dirty="0">
+                <a:solidFill>
+                  <a:srgbClr val="FFFFFF"/>
+                </a:solidFill>
+                <a:latin typeface="Calibri" pitchFamily="34" charset="0"/>
+                <a:ea typeface="Calibri" pitchFamily="34" charset="-122"/>
+                <a:cs typeface="Calibri" pitchFamily="34" charset="-120"/>
+              </a:rPr>
+              <a:t>pratyaya-beta.vercel.app</a:t>
+            </a:r>
+            <a:pPr indent="0" marL="0">
+              <a:buNone/>
+            </a:pPr>
+            <a:r>
+              <a:rPr lang="en-US" sz="1100" b="1" spc="150" kern="0" dirty="0">
+                <a:solidFill>
+                  <a:srgbClr val="8FD7B8"/>
+                </a:solidFill>
+                <a:latin typeface="Calibri" pitchFamily="34" charset="0"/>
+                <a:ea typeface="Calibri" pitchFamily="34" charset="-122"/>
+                <a:cs typeface="Calibri" pitchFamily="34" charset="-120"/>
+              </a:rPr>
+              <a:t>        CODE  </a:t>
+            </a:r>
+            <a:pPr indent="0" marL="0">
+              <a:buNone/>
+            </a:pPr>
+            <a:r>
+              <a:rPr lang="en-US" sz="1500" b="1" dirty="0">
+                <a:solidFill>
+                  <a:srgbClr val="FFFFFF"/>
+                </a:solidFill>
+                <a:latin typeface="Calibri" pitchFamily="34" charset="0"/>
+                <a:ea typeface="Calibri" pitchFamily="34" charset="-122"/>
+                <a:cs typeface="Calibri" pitchFamily="34" charset="-120"/>
+              </a:rPr>
+              <a:t>github.com/Nishantttt-ui/pratyaya</a:t>
+            </a:r>
+            <a:endParaRPr lang="en-US" sz="1100" dirty="0"/>
+          </a:p>
+        </p:txBody>
+      </p:sp>
+      <p:sp>
+        <p:nvSpPr>
+          <p:cNvPr id="13" name="Shape 11"/>
+          <p:cNvSpPr/>
+          <p:nvPr/>
+        </p:nvSpPr>
+        <p:spPr>
+          <a:xfrm>
+            <a:off x="502920" y="5596128"/>
             <a:ext cx="3840480" cy="0"/>
           </a:xfrm>
           <a:prstGeom prst="line">
@@ -3962,14 +4154,14 @@
       </p:sp>
       <p:sp>
         <p:nvSpPr>
-          <p:cNvPr id="12" name="Text 10"/>
-          <p:cNvSpPr txBox="1"/>
-          <p:nvPr/>
-        </p:nvSpPr>
-        <p:spPr>
-          <a:xfrm>
-            <a:off x="502920" y="5120640"/>
-            <a:ext cx="9601200" cy="822960"/>
+          <p:cNvPr id="14" name="Text 12"/>
+          <p:cNvSpPr txBox="1"/>
+          <p:nvPr/>
+        </p:nvSpPr>
+        <p:spPr>
+          <a:xfrm>
+            <a:off x="502920" y="5760720"/>
+            <a:ext cx="9601200" cy="731520"/>
           </a:xfrm>
           <a:prstGeom prst="rect">
             <a:avLst/>
@@ -3983,12 +4175,12 @@
           <a:p>
             <a:pPr indent="0" marL="0">
               <a:lnSpc>
-                <a:spcPts val="1900"/>
+                <a:spcPts val="1800"/>
               </a:lnSpc>
               <a:buNone/>
             </a:pPr>
             <a:r>
-              <a:rPr lang="en-US" sz="1300" i="1" dirty="0">
+              <a:rPr lang="en-US" sz="1250" i="1" dirty="0">
                 <a:solidFill>
                   <a:srgbClr val="FFFFFF"/>
                 </a:solidFill>
@@ -4000,12 +4192,12 @@
             </a:r>
             <a:pPr indent="0" marL="0">
               <a:lnSpc>
-                <a:spcPts val="1900"/>
+                <a:spcPts val="1800"/>
               </a:lnSpc>
               <a:buNone/>
             </a:pPr>
             <a:r>
-              <a:rPr lang="en-US" sz="1300" dirty="0">
+              <a:rPr lang="en-US" sz="1250" dirty="0">
                 <a:solidFill>
                   <a:srgbClr val="93A0AA"/>
                 </a:solidFill>
@@ -4017,12 +4209,12 @@
             </a:r>
             <a:pPr indent="0" marL="0">
               <a:lnSpc>
-                <a:spcPts val="1900"/>
+                <a:spcPts val="1800"/>
               </a:lnSpc>
               <a:buNone/>
             </a:pPr>
             <a:r>
-              <a:rPr lang="en-US" sz="1300" i="1" dirty="0">
+              <a:rPr lang="en-US" sz="1250" i="1" dirty="0">
                 <a:solidFill>
                   <a:srgbClr val="FFFFFF"/>
                 </a:solidFill>
@@ -4034,12 +4226,12 @@
             </a:r>
             <a:pPr indent="0" marL="0">
               <a:lnSpc>
-                <a:spcPts val="1900"/>
+                <a:spcPts val="1800"/>
               </a:lnSpc>
               <a:buNone/>
             </a:pPr>
             <a:r>
-              <a:rPr lang="en-US" sz="1300" dirty="0">
+              <a:rPr lang="en-US" sz="1250" dirty="0">
                 <a:solidFill>
                   <a:srgbClr val="93A0AA"/>
                 </a:solidFill>
@@ -4051,12 +4243,12 @@
             </a:r>
             <a:pPr indent="0" marL="0">
               <a:lnSpc>
-                <a:spcPts val="1900"/>
+                <a:spcPts val="1800"/>
               </a:lnSpc>
               <a:buNone/>
             </a:pPr>
             <a:r>
-              <a:rPr lang="en-US" sz="1300" i="1" dirty="0">
+              <a:rPr lang="en-US" sz="1250" i="1" dirty="0">
                 <a:solidFill>
                   <a:srgbClr val="FFFFFF"/>
                 </a:solidFill>
@@ -4068,12 +4260,12 @@
             </a:r>
             <a:pPr indent="0" marL="0">
               <a:lnSpc>
-                <a:spcPts val="1900"/>
+                <a:spcPts val="1800"/>
               </a:lnSpc>
               <a:buNone/>
             </a:pPr>
             <a:r>
-              <a:rPr lang="en-US" sz="1300" dirty="0">
+              <a:rPr lang="en-US" sz="1250" dirty="0">
                 <a:solidFill>
                   <a:srgbClr val="93A0AA"/>
                 </a:solidFill>
@@ -4083,17 +4275,17 @@
               </a:rPr>
               <a:t>, to believe.</a:t>
             </a:r>
-            <a:endParaRPr lang="en-US" sz="1300" dirty="0"/>
+            <a:endParaRPr lang="en-US" sz="1250" dirty="0"/>
           </a:p>
           <a:p>
             <a:pPr indent="0" marL="0">
               <a:lnSpc>
-                <a:spcPts val="1900"/>
+                <a:spcPts val="1800"/>
               </a:lnSpc>
               <a:buNone/>
             </a:pPr>
             <a:r>
-              <a:rPr lang="en-US" sz="1300" dirty="0">
+              <a:rPr lang="en-US" sz="1250" dirty="0">
                 <a:solidFill>
                   <a:srgbClr val="93A0AA"/>
                 </a:solidFill>
@@ -4103,7 +4295,7 @@
               </a:rPr>
               <a:t>Both name the same thing: a lender's belief that a borrower will repay.</a:t>
             </a:r>
-            <a:endParaRPr lang="en-US" sz="1300" dirty="0"/>
+            <a:endParaRPr lang="en-US" sz="1250" dirty="0"/>
           </a:p>
         </p:txBody>
       </p:sp>
@@ -23577,6 +23769,1071 @@
     <p:bg>
       <p:bgPr>
         <a:solidFill>
+          <a:srgbClr val="FFFFFF"/>
+        </a:solidFill>
+      </p:bgPr>
+    </p:bg>
+    <p:spTree>
+      <p:nvGrpSpPr>
+        <p:cNvPr id="1" name=""/>
+        <p:cNvGrpSpPr/>
+        <p:nvPr/>
+      </p:nvGrpSpPr>
+      <p:grpSpPr>
+        <a:xfrm>
+          <a:off x="0" y="0"/>
+          <a:ext cx="0" cy="0"/>
+          <a:chOff x="0" y="0"/>
+          <a:chExt cx="0" cy="0"/>
+        </a:xfrm>
+      </p:grpSpPr>
+      <p:sp>
+        <p:nvSpPr>
+          <p:cNvPr id="2" name="Text 0"/>
+          <p:cNvSpPr txBox="1"/>
+          <p:nvPr/>
+        </p:nvSpPr>
+        <p:spPr>
+          <a:xfrm>
+            <a:off x="502920" y="411480"/>
+            <a:ext cx="11155680" cy="1051560"/>
+          </a:xfrm>
+          <a:prstGeom prst="rect">
+            <a:avLst/>
+          </a:prstGeom>
+          <a:noFill/>
+          <a:ln/>
+        </p:spPr>
+        <p:txBody>
+          <a:bodyPr wrap="square" lIns="0" tIns="0" rIns="0" bIns="0" rtlCol="0" anchor="t"/>
+          <a:lstStyle/>
+          <a:p>
+            <a:pPr indent="0" marL="0">
+              <a:buNone/>
+            </a:pPr>
+            <a:r>
+              <a:rPr lang="en-US" sz="3000" dirty="0">
+                <a:solidFill>
+                  <a:srgbClr val="16232E"/>
+                </a:solidFill>
+                <a:latin typeface="Cambria" pitchFamily="34" charset="0"/>
+                <a:ea typeface="Cambria" pitchFamily="34" charset="-122"/>
+                <a:cs typeface="Cambria" pitchFamily="34" charset="-120"/>
+              </a:rPr>
+              <a:t>Everything in this deck is running, and open</a:t>
+            </a:r>
+            <a:endParaRPr lang="en-US" sz="3000" dirty="0"/>
+          </a:p>
+        </p:txBody>
+      </p:sp>
+      <p:sp>
+        <p:nvSpPr>
+          <p:cNvPr id="3" name="Text 1"/>
+          <p:cNvSpPr txBox="1"/>
+          <p:nvPr/>
+        </p:nvSpPr>
+        <p:spPr>
+          <a:xfrm>
+            <a:off x="502920" y="896112"/>
+            <a:ext cx="10881360" cy="685800"/>
+          </a:xfrm>
+          <a:prstGeom prst="rect">
+            <a:avLst/>
+          </a:prstGeom>
+          <a:noFill/>
+          <a:ln/>
+        </p:spPr>
+        <p:txBody>
+          <a:bodyPr wrap="square" lIns="0" tIns="0" rIns="0" bIns="0" rtlCol="0" anchor="t"/>
+          <a:lstStyle/>
+          <a:p>
+            <a:pPr indent="0" marL="0">
+              <a:lnSpc>
+                <a:spcPts val="2000"/>
+              </a:lnSpc>
+              <a:buNone/>
+            </a:pPr>
+            <a:r>
+              <a:rPr lang="en-US" sz="1250" dirty="0">
+                <a:solidFill>
+                  <a:srgbClr val="5A6570"/>
+                </a:solidFill>
+                <a:latin typeface="Calibri" pitchFamily="34" charset="0"/>
+                <a:ea typeface="Calibri" pitchFamily="34" charset="-122"/>
+                <a:cs typeface="Calibri" pitchFamily="34" charset="-120"/>
+              </a:rPr>
+              <a:t>Not a prototype on a laptop. Every figure quoted here regenerates from a committed script, and the system serves real decisions over the public internet.</a:t>
+            </a:r>
+            <a:endParaRPr lang="en-US" sz="1250" dirty="0"/>
+          </a:p>
+        </p:txBody>
+      </p:sp>
+      <p:sp>
+        <p:nvSpPr>
+          <p:cNvPr id="4" name="Shape 2"/>
+          <p:cNvSpPr/>
+          <p:nvPr/>
+        </p:nvSpPr>
+        <p:spPr>
+          <a:xfrm>
+            <a:off x="502920" y="1536192"/>
+            <a:ext cx="11155680" cy="1389888"/>
+          </a:xfrm>
+          <a:prstGeom prst="roundRect">
+            <a:avLst>
+              <a:gd name="adj" fmla="val 5921"/>
+            </a:avLst>
+          </a:prstGeom>
+          <a:solidFill>
+            <a:srgbClr val="E3F0E9"/>
+          </a:solidFill>
+          <a:ln w="9525">
+            <a:solidFill>
+              <a:srgbClr val="0E6B4F"/>
+            </a:solidFill>
+            <a:prstDash val="solid"/>
+          </a:ln>
+          <a:effectLst>
+            <a:outerShdw sx="100000" sy="100000" kx="0" ky="0" algn="bl" rotWithShape="0" blurRad="101600" dist="25400" dir="5400000">
+              <a:srgbClr val="9AA5AE">
+                <a:alpha val="22000"/>
+              </a:srgbClr>
+            </a:outerShdw>
+          </a:effectLst>
+        </p:spPr>
+      </p:sp>
+      <p:sp>
+        <p:nvSpPr>
+          <p:cNvPr id="5" name="Text 3"/>
+          <p:cNvSpPr txBox="1"/>
+          <p:nvPr/>
+        </p:nvSpPr>
+        <p:spPr>
+          <a:xfrm>
+            <a:off x="822960" y="1700784"/>
+            <a:ext cx="10515600" cy="256032"/>
+          </a:xfrm>
+          <a:prstGeom prst="rect">
+            <a:avLst/>
+          </a:prstGeom>
+          <a:noFill/>
+          <a:ln/>
+        </p:spPr>
+        <p:txBody>
+          <a:bodyPr wrap="square" lIns="0" tIns="0" rIns="0" bIns="0" rtlCol="0" anchor="ctr"/>
+          <a:lstStyle/>
+          <a:p>
+            <a:pPr indent="0" marL="0">
+              <a:buNone/>
+            </a:pPr>
+            <a:r>
+              <a:rPr lang="en-US" sz="1100" b="1" spc="180" kern="0" dirty="0">
+                <a:solidFill>
+                  <a:srgbClr val="0E6B4F"/>
+                </a:solidFill>
+                <a:latin typeface="Calibri" pitchFamily="34" charset="0"/>
+                <a:ea typeface="Calibri" pitchFamily="34" charset="-122"/>
+                <a:cs typeface="Calibri" pitchFamily="34" charset="-120"/>
+              </a:rPr>
+              <a:t>THE RUNNING SYSTEM</a:t>
+            </a:r>
+            <a:endParaRPr lang="en-US" sz="1100" dirty="0"/>
+          </a:p>
+        </p:txBody>
+      </p:sp>
+      <p:sp>
+        <p:nvSpPr>
+          <p:cNvPr id="6" name="Text 4"/>
+          <p:cNvSpPr txBox="1"/>
+          <p:nvPr/>
+        </p:nvSpPr>
+        <p:spPr>
+          <a:xfrm>
+            <a:off x="822960" y="1956816"/>
+            <a:ext cx="10515600" cy="457200"/>
+          </a:xfrm>
+          <a:prstGeom prst="rect">
+            <a:avLst/>
+          </a:prstGeom>
+          <a:noFill/>
+          <a:ln/>
+        </p:spPr>
+        <p:txBody>
+          <a:bodyPr wrap="square" lIns="0" tIns="0" rIns="0" bIns="0" rtlCol="0" anchor="ctr"/>
+          <a:lstStyle/>
+          <a:p>
+            <a:pPr indent="0" marL="0">
+              <a:buNone/>
+            </a:pPr>
+            <a:r>
+              <a:rPr lang="en-US" sz="3000" b="1" dirty="0">
+                <a:solidFill>
+                  <a:srgbClr val="16232E"/>
+                </a:solidFill>
+                <a:latin typeface="Cambria" pitchFamily="34" charset="0"/>
+                <a:ea typeface="Cambria" pitchFamily="34" charset="-122"/>
+                <a:cs typeface="Cambria" pitchFamily="34" charset="-120"/>
+              </a:rPr>
+              <a:t>pratyaya-beta.vercel.app</a:t>
+            </a:r>
+            <a:endParaRPr lang="en-US" sz="3000" dirty="0"/>
+          </a:p>
+        </p:txBody>
+      </p:sp>
+      <p:sp>
+        <p:nvSpPr>
+          <p:cNvPr id="7" name="Text 5"/>
+          <p:cNvSpPr txBox="1"/>
+          <p:nvPr/>
+        </p:nvSpPr>
+        <p:spPr>
+          <a:xfrm>
+            <a:off x="822960" y="2432304"/>
+            <a:ext cx="10515600" cy="365760"/>
+          </a:xfrm>
+          <a:prstGeom prst="rect">
+            <a:avLst/>
+          </a:prstGeom>
+          <a:noFill/>
+          <a:ln/>
+        </p:spPr>
+        <p:txBody>
+          <a:bodyPr wrap="square" lIns="0" tIns="0" rIns="0" bIns="0" rtlCol="0" anchor="ctr"/>
+          <a:lstStyle/>
+          <a:p>
+            <a:pPr indent="0" marL="0">
+              <a:buNone/>
+            </a:pPr>
+            <a:r>
+              <a:rPr lang="en-US" sz="1250" dirty="0">
+                <a:solidFill>
+                  <a:srgbClr val="2F4A40"/>
+                </a:solidFill>
+                <a:latin typeface="Calibri" pitchFamily="34" charset="0"/>
+                <a:ea typeface="Calibri" pitchFamily="34" charset="-122"/>
+                <a:cs typeface="Calibri" pitchFamily="34" charset="-120"/>
+              </a:rPr>
+              <a:t>Sign in as  underwriter / demo-underwriter-pw  for the full decision, or  applicant / demo-applicant-pw  for the view a borrower receives.</a:t>
+            </a:r>
+            <a:endParaRPr lang="en-US" sz="1250" dirty="0"/>
+          </a:p>
+        </p:txBody>
+      </p:sp>
+      <p:sp>
+        <p:nvSpPr>
+          <p:cNvPr id="8" name="Shape 6"/>
+          <p:cNvSpPr/>
+          <p:nvPr/>
+        </p:nvSpPr>
+        <p:spPr>
+          <a:xfrm>
+            <a:off x="502920" y="3072384"/>
+            <a:ext cx="11155680" cy="1389888"/>
+          </a:xfrm>
+          <a:prstGeom prst="roundRect">
+            <a:avLst>
+              <a:gd name="adj" fmla="val 5921"/>
+            </a:avLst>
+          </a:prstGeom>
+          <a:solidFill>
+            <a:srgbClr val="16232E"/>
+          </a:solidFill>
+          <a:ln/>
+          <a:effectLst>
+            <a:outerShdw sx="100000" sy="100000" kx="0" ky="0" algn="bl" rotWithShape="0" blurRad="101600" dist="25400" dir="5400000">
+              <a:srgbClr val="9AA5AE">
+                <a:alpha val="22000"/>
+              </a:srgbClr>
+            </a:outerShdw>
+          </a:effectLst>
+        </p:spPr>
+      </p:sp>
+      <p:sp>
+        <p:nvSpPr>
+          <p:cNvPr id="9" name="Text 7"/>
+          <p:cNvSpPr txBox="1"/>
+          <p:nvPr/>
+        </p:nvSpPr>
+        <p:spPr>
+          <a:xfrm>
+            <a:off x="822960" y="3236976"/>
+            <a:ext cx="10515600" cy="256032"/>
+          </a:xfrm>
+          <a:prstGeom prst="rect">
+            <a:avLst/>
+          </a:prstGeom>
+          <a:noFill/>
+          <a:ln/>
+        </p:spPr>
+        <p:txBody>
+          <a:bodyPr wrap="square" lIns="0" tIns="0" rIns="0" bIns="0" rtlCol="0" anchor="ctr"/>
+          <a:lstStyle/>
+          <a:p>
+            <a:pPr indent="0" marL="0">
+              <a:buNone/>
+            </a:pPr>
+            <a:r>
+              <a:rPr lang="en-US" sz="1100" b="1" spc="180" kern="0" dirty="0">
+                <a:solidFill>
+                  <a:srgbClr val="8FD7B8"/>
+                </a:solidFill>
+                <a:latin typeface="Calibri" pitchFamily="34" charset="0"/>
+                <a:ea typeface="Calibri" pitchFamily="34" charset="-122"/>
+                <a:cs typeface="Calibri" pitchFamily="34" charset="-120"/>
+              </a:rPr>
+              <a:t>THE CODE</a:t>
+            </a:r>
+            <a:endParaRPr lang="en-US" sz="1100" dirty="0"/>
+          </a:p>
+        </p:txBody>
+      </p:sp>
+      <p:sp>
+        <p:nvSpPr>
+          <p:cNvPr id="10" name="Text 8"/>
+          <p:cNvSpPr txBox="1"/>
+          <p:nvPr/>
+        </p:nvSpPr>
+        <p:spPr>
+          <a:xfrm>
+            <a:off x="822960" y="3493008"/>
+            <a:ext cx="10515600" cy="457200"/>
+          </a:xfrm>
+          <a:prstGeom prst="rect">
+            <a:avLst/>
+          </a:prstGeom>
+          <a:noFill/>
+          <a:ln/>
+        </p:spPr>
+        <p:txBody>
+          <a:bodyPr wrap="square" lIns="0" tIns="0" rIns="0" bIns="0" rtlCol="0" anchor="ctr"/>
+          <a:lstStyle/>
+          <a:p>
+            <a:pPr indent="0" marL="0">
+              <a:buNone/>
+            </a:pPr>
+            <a:r>
+              <a:rPr lang="en-US" sz="3000" b="1" dirty="0">
+                <a:solidFill>
+                  <a:srgbClr val="FFFFFF"/>
+                </a:solidFill>
+                <a:latin typeface="Cambria" pitchFamily="34" charset="0"/>
+                <a:ea typeface="Cambria" pitchFamily="34" charset="-122"/>
+                <a:cs typeface="Cambria" pitchFamily="34" charset="-120"/>
+              </a:rPr>
+              <a:t>github.com/Nishantttt-ui/pratyaya</a:t>
+            </a:r>
+            <a:endParaRPr lang="en-US" sz="3000" dirty="0"/>
+          </a:p>
+        </p:txBody>
+      </p:sp>
+      <p:sp>
+        <p:nvSpPr>
+          <p:cNvPr id="11" name="Text 9"/>
+          <p:cNvSpPr txBox="1"/>
+          <p:nvPr/>
+        </p:nvSpPr>
+        <p:spPr>
+          <a:xfrm>
+            <a:off x="822960" y="3968496"/>
+            <a:ext cx="10515600" cy="365760"/>
+          </a:xfrm>
+          <a:prstGeom prst="rect">
+            <a:avLst/>
+          </a:prstGeom>
+          <a:noFill/>
+          <a:ln/>
+        </p:spPr>
+        <p:txBody>
+          <a:bodyPr wrap="square" lIns="0" tIns="0" rIns="0" bIns="0" rtlCol="0" anchor="ctr"/>
+          <a:lstStyle/>
+          <a:p>
+            <a:pPr indent="0" marL="0">
+              <a:buNone/>
+            </a:pPr>
+            <a:r>
+              <a:rPr lang="en-US" sz="1250" dirty="0">
+                <a:solidFill>
+                  <a:srgbClr val="C2CDD6"/>
+                </a:solidFill>
+                <a:latin typeface="Calibri" pitchFamily="34" charset="0"/>
+                <a:ea typeface="Calibri" pitchFamily="34" charset="-122"/>
+                <a:cs typeface="Calibri" pitchFamily="34" charset="-120"/>
+              </a:rPr>
+              <a:t>Public. 34 commits, CI green on every push, 136 tests, README with setup for the API and the interface, and a model card.</a:t>
+            </a:r>
+            <a:endParaRPr lang="en-US" sz="1250" dirty="0"/>
+          </a:p>
+        </p:txBody>
+      </p:sp>
+      <p:sp>
+        <p:nvSpPr>
+          <p:cNvPr id="12" name="Shape 10"/>
+          <p:cNvSpPr/>
+          <p:nvPr/>
+        </p:nvSpPr>
+        <p:spPr>
+          <a:xfrm>
+            <a:off x="502920" y="4626864"/>
+            <a:ext cx="2638044" cy="1225296"/>
+          </a:xfrm>
+          <a:prstGeom prst="roundRect">
+            <a:avLst>
+              <a:gd name="adj" fmla="val 6716"/>
+            </a:avLst>
+          </a:prstGeom>
+          <a:solidFill>
+            <a:srgbClr val="FFFFFF"/>
+          </a:solidFill>
+          <a:ln w="9525">
+            <a:solidFill>
+              <a:srgbClr val="DEE4E0"/>
+            </a:solidFill>
+            <a:prstDash val="solid"/>
+          </a:ln>
+          <a:effectLst>
+            <a:outerShdw sx="100000" sy="100000" kx="0" ky="0" algn="bl" rotWithShape="0" blurRad="101600" dist="25400" dir="5400000">
+              <a:srgbClr val="9AA5AE">
+                <a:alpha val="22000"/>
+              </a:srgbClr>
+            </a:outerShdw>
+          </a:effectLst>
+        </p:spPr>
+      </p:sp>
+      <p:sp>
+        <p:nvSpPr>
+          <p:cNvPr id="13" name="Text 11"/>
+          <p:cNvSpPr txBox="1"/>
+          <p:nvPr/>
+        </p:nvSpPr>
+        <p:spPr>
+          <a:xfrm>
+            <a:off x="704088" y="4754880"/>
+            <a:ext cx="2235708" cy="438912"/>
+          </a:xfrm>
+          <a:prstGeom prst="rect">
+            <a:avLst/>
+          </a:prstGeom>
+          <a:noFill/>
+          <a:ln/>
+        </p:spPr>
+        <p:txBody>
+          <a:bodyPr wrap="square" lIns="0" tIns="0" rIns="0" bIns="0" rtlCol="0" anchor="ctr"/>
+          <a:lstStyle/>
+          <a:p>
+            <a:pPr indent="0" marL="0">
+              <a:buNone/>
+            </a:pPr>
+            <a:r>
+              <a:rPr lang="en-US" sz="3000" b="1" dirty="0">
+                <a:solidFill>
+                  <a:srgbClr val="0E6B4F"/>
+                </a:solidFill>
+                <a:latin typeface="Cambria" pitchFamily="34" charset="0"/>
+                <a:ea typeface="Cambria" pitchFamily="34" charset="-122"/>
+                <a:cs typeface="Cambria" pitchFamily="34" charset="-120"/>
+              </a:rPr>
+              <a:t>136</a:t>
+            </a:r>
+            <a:endParaRPr lang="en-US" sz="3000" dirty="0"/>
+          </a:p>
+        </p:txBody>
+      </p:sp>
+      <p:sp>
+        <p:nvSpPr>
+          <p:cNvPr id="14" name="Text 12"/>
+          <p:cNvSpPr txBox="1"/>
+          <p:nvPr/>
+        </p:nvSpPr>
+        <p:spPr>
+          <a:xfrm>
+            <a:off x="704088" y="5175504"/>
+            <a:ext cx="2235708" cy="237744"/>
+          </a:xfrm>
+          <a:prstGeom prst="rect">
+            <a:avLst/>
+          </a:prstGeom>
+          <a:noFill/>
+          <a:ln/>
+        </p:spPr>
+        <p:txBody>
+          <a:bodyPr wrap="square" lIns="0" tIns="0" rIns="0" bIns="0" rtlCol="0" anchor="ctr"/>
+          <a:lstStyle/>
+          <a:p>
+            <a:pPr indent="0" marL="0">
+              <a:buNone/>
+            </a:pPr>
+            <a:r>
+              <a:rPr lang="en-US" sz="1250" b="1" dirty="0">
+                <a:solidFill>
+                  <a:srgbClr val="16232E"/>
+                </a:solidFill>
+                <a:latin typeface="Calibri" pitchFamily="34" charset="0"/>
+                <a:ea typeface="Calibri" pitchFamily="34" charset="-122"/>
+                <a:cs typeface="Calibri" pitchFamily="34" charset="-120"/>
+              </a:rPr>
+              <a:t>tests passing</a:t>
+            </a:r>
+            <a:endParaRPr lang="en-US" sz="1250" dirty="0"/>
+          </a:p>
+        </p:txBody>
+      </p:sp>
+      <p:sp>
+        <p:nvSpPr>
+          <p:cNvPr id="15" name="Text 13"/>
+          <p:cNvSpPr txBox="1"/>
+          <p:nvPr/>
+        </p:nvSpPr>
+        <p:spPr>
+          <a:xfrm>
+            <a:off x="704088" y="5422392"/>
+            <a:ext cx="2235708" cy="402336"/>
+          </a:xfrm>
+          <a:prstGeom prst="rect">
+            <a:avLst/>
+          </a:prstGeom>
+          <a:noFill/>
+          <a:ln/>
+        </p:spPr>
+        <p:txBody>
+          <a:bodyPr wrap="square" lIns="0" tIns="0" rIns="0" bIns="0" rtlCol="0" anchor="ctr"/>
+          <a:lstStyle/>
+          <a:p>
+            <a:pPr indent="0" marL="0">
+              <a:lnSpc>
+                <a:spcPts val="1200"/>
+              </a:lnSpc>
+              <a:buNone/>
+            </a:pPr>
+            <a:r>
+              <a:rPr lang="en-US" sz="1050" dirty="0">
+                <a:solidFill>
+                  <a:srgbClr val="5A6570"/>
+                </a:solidFill>
+                <a:latin typeface="Calibri" pitchFamily="34" charset="0"/>
+                <a:ea typeface="Calibri" pitchFamily="34" charset="-122"/>
+                <a:cs typeface="Calibri" pitchFamily="34" charset="-120"/>
+              </a:rPr>
+              <a:t>guarding the invariants that were expensive to get right</a:t>
+            </a:r>
+            <a:endParaRPr lang="en-US" sz="1050" dirty="0"/>
+          </a:p>
+        </p:txBody>
+      </p:sp>
+      <p:sp>
+        <p:nvSpPr>
+          <p:cNvPr id="16" name="Shape 14"/>
+          <p:cNvSpPr/>
+          <p:nvPr/>
+        </p:nvSpPr>
+        <p:spPr>
+          <a:xfrm>
+            <a:off x="3342132" y="4626864"/>
+            <a:ext cx="2638044" cy="1225296"/>
+          </a:xfrm>
+          <a:prstGeom prst="roundRect">
+            <a:avLst>
+              <a:gd name="adj" fmla="val 6716"/>
+            </a:avLst>
+          </a:prstGeom>
+          <a:solidFill>
+            <a:srgbClr val="FFFFFF"/>
+          </a:solidFill>
+          <a:ln w="9525">
+            <a:solidFill>
+              <a:srgbClr val="DEE4E0"/>
+            </a:solidFill>
+            <a:prstDash val="solid"/>
+          </a:ln>
+          <a:effectLst>
+            <a:outerShdw sx="100000" sy="100000" kx="0" ky="0" algn="bl" rotWithShape="0" blurRad="101600" dist="25400" dir="5400000">
+              <a:srgbClr val="9AA5AE">
+                <a:alpha val="22000"/>
+              </a:srgbClr>
+            </a:outerShdw>
+          </a:effectLst>
+        </p:spPr>
+      </p:sp>
+      <p:sp>
+        <p:nvSpPr>
+          <p:cNvPr id="17" name="Text 15"/>
+          <p:cNvSpPr txBox="1"/>
+          <p:nvPr/>
+        </p:nvSpPr>
+        <p:spPr>
+          <a:xfrm>
+            <a:off x="3543300" y="4754880"/>
+            <a:ext cx="2235708" cy="438912"/>
+          </a:xfrm>
+          <a:prstGeom prst="rect">
+            <a:avLst/>
+          </a:prstGeom>
+          <a:noFill/>
+          <a:ln/>
+        </p:spPr>
+        <p:txBody>
+          <a:bodyPr wrap="square" lIns="0" tIns="0" rIns="0" bIns="0" rtlCol="0" anchor="ctr"/>
+          <a:lstStyle/>
+          <a:p>
+            <a:pPr indent="0" marL="0">
+              <a:buNone/>
+            </a:pPr>
+            <a:r>
+              <a:rPr lang="en-US" sz="3000" b="1" dirty="0">
+                <a:solidFill>
+                  <a:srgbClr val="0E6B4F"/>
+                </a:solidFill>
+                <a:latin typeface="Cambria" pitchFamily="34" charset="0"/>
+                <a:ea typeface="Cambria" pitchFamily="34" charset="-122"/>
+                <a:cs typeface="Cambria" pitchFamily="34" charset="-120"/>
+              </a:rPr>
+              <a:t>10</a:t>
+            </a:r>
+            <a:endParaRPr lang="en-US" sz="3000" dirty="0"/>
+          </a:p>
+        </p:txBody>
+      </p:sp>
+      <p:sp>
+        <p:nvSpPr>
+          <p:cNvPr id="18" name="Text 16"/>
+          <p:cNvSpPr txBox="1"/>
+          <p:nvPr/>
+        </p:nvSpPr>
+        <p:spPr>
+          <a:xfrm>
+            <a:off x="3543300" y="5175504"/>
+            <a:ext cx="2235708" cy="237744"/>
+          </a:xfrm>
+          <a:prstGeom prst="rect">
+            <a:avLst/>
+          </a:prstGeom>
+          <a:noFill/>
+          <a:ln/>
+        </p:spPr>
+        <p:txBody>
+          <a:bodyPr wrap="square" lIns="0" tIns="0" rIns="0" bIns="0" rtlCol="0" anchor="ctr"/>
+          <a:lstStyle/>
+          <a:p>
+            <a:pPr indent="0" marL="0">
+              <a:buNone/>
+            </a:pPr>
+            <a:r>
+              <a:rPr lang="en-US" sz="1250" b="1" dirty="0">
+                <a:solidFill>
+                  <a:srgbClr val="16232E"/>
+                </a:solidFill>
+                <a:latin typeface="Calibri" pitchFamily="34" charset="0"/>
+                <a:ea typeface="Calibri" pitchFamily="34" charset="-122"/>
+                <a:cs typeface="Calibri" pitchFamily="34" charset="-120"/>
+              </a:rPr>
+              <a:t>charts</a:t>
+            </a:r>
+            <a:endParaRPr lang="en-US" sz="1250" dirty="0"/>
+          </a:p>
+        </p:txBody>
+      </p:sp>
+      <p:sp>
+        <p:nvSpPr>
+          <p:cNvPr id="19" name="Text 17"/>
+          <p:cNvSpPr txBox="1"/>
+          <p:nvPr/>
+        </p:nvSpPr>
+        <p:spPr>
+          <a:xfrm>
+            <a:off x="3543300" y="5422392"/>
+            <a:ext cx="2235708" cy="402336"/>
+          </a:xfrm>
+          <a:prstGeom prst="rect">
+            <a:avLst/>
+          </a:prstGeom>
+          <a:noFill/>
+          <a:ln/>
+        </p:spPr>
+        <p:txBody>
+          <a:bodyPr wrap="square" lIns="0" tIns="0" rIns="0" bIns="0" rtlCol="0" anchor="ctr"/>
+          <a:lstStyle/>
+          <a:p>
+            <a:pPr indent="0" marL="0">
+              <a:lnSpc>
+                <a:spcPts val="1200"/>
+              </a:lnSpc>
+              <a:buNone/>
+            </a:pPr>
+            <a:r>
+              <a:rPr lang="en-US" sz="1050" dirty="0">
+                <a:solidFill>
+                  <a:srgbClr val="5A6570"/>
+                </a:solidFill>
+                <a:latin typeface="Calibri" pitchFamily="34" charset="0"/>
+                <a:ea typeface="Calibri" pitchFamily="34" charset="-122"/>
+                <a:cs typeface="Calibri" pitchFamily="34" charset="-120"/>
+              </a:rPr>
+              <a:t>each regenerated from a committed measurement file</a:t>
+            </a:r>
+            <a:endParaRPr lang="en-US" sz="1050" dirty="0"/>
+          </a:p>
+        </p:txBody>
+      </p:sp>
+      <p:sp>
+        <p:nvSpPr>
+          <p:cNvPr id="20" name="Shape 18"/>
+          <p:cNvSpPr/>
+          <p:nvPr/>
+        </p:nvSpPr>
+        <p:spPr>
+          <a:xfrm>
+            <a:off x="6181344" y="4626864"/>
+            <a:ext cx="2638044" cy="1225296"/>
+          </a:xfrm>
+          <a:prstGeom prst="roundRect">
+            <a:avLst>
+              <a:gd name="adj" fmla="val 6716"/>
+            </a:avLst>
+          </a:prstGeom>
+          <a:solidFill>
+            <a:srgbClr val="FFFFFF"/>
+          </a:solidFill>
+          <a:ln w="9525">
+            <a:solidFill>
+              <a:srgbClr val="DEE4E0"/>
+            </a:solidFill>
+            <a:prstDash val="solid"/>
+          </a:ln>
+          <a:effectLst>
+            <a:outerShdw sx="100000" sy="100000" kx="0" ky="0" algn="bl" rotWithShape="0" blurRad="101600" dist="25400" dir="5400000">
+              <a:srgbClr val="9AA5AE">
+                <a:alpha val="22000"/>
+              </a:srgbClr>
+            </a:outerShdw>
+          </a:effectLst>
+        </p:spPr>
+      </p:sp>
+      <p:sp>
+        <p:nvSpPr>
+          <p:cNvPr id="21" name="Text 19"/>
+          <p:cNvSpPr txBox="1"/>
+          <p:nvPr/>
+        </p:nvSpPr>
+        <p:spPr>
+          <a:xfrm>
+            <a:off x="6382512" y="4754880"/>
+            <a:ext cx="2235708" cy="438912"/>
+          </a:xfrm>
+          <a:prstGeom prst="rect">
+            <a:avLst/>
+          </a:prstGeom>
+          <a:noFill/>
+          <a:ln/>
+        </p:spPr>
+        <p:txBody>
+          <a:bodyPr wrap="square" lIns="0" tIns="0" rIns="0" bIns="0" rtlCol="0" anchor="ctr"/>
+          <a:lstStyle/>
+          <a:p>
+            <a:pPr indent="0" marL="0">
+              <a:buNone/>
+            </a:pPr>
+            <a:r>
+              <a:rPr lang="en-US" sz="3000" b="1" dirty="0">
+                <a:solidFill>
+                  <a:srgbClr val="0E6B4F"/>
+                </a:solidFill>
+                <a:latin typeface="Cambria" pitchFamily="34" charset="0"/>
+                <a:ea typeface="Cambria" pitchFamily="34" charset="-122"/>
+                <a:cs typeface="Cambria" pitchFamily="34" charset="-120"/>
+              </a:rPr>
+              <a:t>37</a:t>
+            </a:r>
+            <a:endParaRPr lang="en-US" sz="3000" dirty="0"/>
+          </a:p>
+        </p:txBody>
+      </p:sp>
+      <p:sp>
+        <p:nvSpPr>
+          <p:cNvPr id="22" name="Text 20"/>
+          <p:cNvSpPr txBox="1"/>
+          <p:nvPr/>
+        </p:nvSpPr>
+        <p:spPr>
+          <a:xfrm>
+            <a:off x="6382512" y="5175504"/>
+            <a:ext cx="2235708" cy="237744"/>
+          </a:xfrm>
+          <a:prstGeom prst="rect">
+            <a:avLst/>
+          </a:prstGeom>
+          <a:noFill/>
+          <a:ln/>
+        </p:spPr>
+        <p:txBody>
+          <a:bodyPr wrap="square" lIns="0" tIns="0" rIns="0" bIns="0" rtlCol="0" anchor="ctr"/>
+          <a:lstStyle/>
+          <a:p>
+            <a:pPr indent="0" marL="0">
+              <a:buNone/>
+            </a:pPr>
+            <a:r>
+              <a:rPr lang="en-US" sz="1250" b="1" dirty="0">
+                <a:solidFill>
+                  <a:srgbClr val="16232E"/>
+                </a:solidFill>
+                <a:latin typeface="Calibri" pitchFamily="34" charset="0"/>
+                <a:ea typeface="Calibri" pitchFamily="34" charset="-122"/>
+                <a:cs typeface="Calibri" pitchFamily="34" charset="-120"/>
+              </a:rPr>
+              <a:t>provisions</a:t>
+            </a:r>
+            <a:endParaRPr lang="en-US" sz="1250" dirty="0"/>
+          </a:p>
+        </p:txBody>
+      </p:sp>
+      <p:sp>
+        <p:nvSpPr>
+          <p:cNvPr id="23" name="Text 21"/>
+          <p:cNvSpPr txBox="1"/>
+          <p:nvPr/>
+        </p:nvSpPr>
+        <p:spPr>
+          <a:xfrm>
+            <a:off x="6382512" y="5422392"/>
+            <a:ext cx="2235708" cy="402336"/>
+          </a:xfrm>
+          <a:prstGeom prst="rect">
+            <a:avLst/>
+          </a:prstGeom>
+          <a:noFill/>
+          <a:ln/>
+        </p:spPr>
+        <p:txBody>
+          <a:bodyPr wrap="square" lIns="0" tIns="0" rIns="0" bIns="0" rtlCol="0" anchor="ctr"/>
+          <a:lstStyle/>
+          <a:p>
+            <a:pPr indent="0" marL="0">
+              <a:lnSpc>
+                <a:spcPts val="1200"/>
+              </a:lnSpc>
+              <a:buNone/>
+            </a:pPr>
+            <a:r>
+              <a:rPr lang="en-US" sz="1050" dirty="0">
+                <a:solidFill>
+                  <a:srgbClr val="5A6570"/>
+                </a:solidFill>
+                <a:latin typeface="Calibri" pitchFamily="34" charset="0"/>
+                <a:ea typeface="Calibri" pitchFamily="34" charset="-122"/>
+                <a:cs typeface="Calibri" pitchFamily="34" charset="-120"/>
+              </a:rPr>
+              <a:t>indexed in pgvector and cited per decision</a:t>
+            </a:r>
+            <a:endParaRPr lang="en-US" sz="1050" dirty="0"/>
+          </a:p>
+        </p:txBody>
+      </p:sp>
+      <p:sp>
+        <p:nvSpPr>
+          <p:cNvPr id="24" name="Shape 22"/>
+          <p:cNvSpPr/>
+          <p:nvPr/>
+        </p:nvSpPr>
+        <p:spPr>
+          <a:xfrm>
+            <a:off x="9020556" y="4626864"/>
+            <a:ext cx="2638044" cy="1225296"/>
+          </a:xfrm>
+          <a:prstGeom prst="roundRect">
+            <a:avLst>
+              <a:gd name="adj" fmla="val 6716"/>
+            </a:avLst>
+          </a:prstGeom>
+          <a:solidFill>
+            <a:srgbClr val="FFFFFF"/>
+          </a:solidFill>
+          <a:ln w="9525">
+            <a:solidFill>
+              <a:srgbClr val="DEE4E0"/>
+            </a:solidFill>
+            <a:prstDash val="solid"/>
+          </a:ln>
+          <a:effectLst>
+            <a:outerShdw sx="100000" sy="100000" kx="0" ky="0" algn="bl" rotWithShape="0" blurRad="101600" dist="25400" dir="5400000">
+              <a:srgbClr val="9AA5AE">
+                <a:alpha val="22000"/>
+              </a:srgbClr>
+            </a:outerShdw>
+          </a:effectLst>
+        </p:spPr>
+      </p:sp>
+      <p:sp>
+        <p:nvSpPr>
+          <p:cNvPr id="25" name="Text 23"/>
+          <p:cNvSpPr txBox="1"/>
+          <p:nvPr/>
+        </p:nvSpPr>
+        <p:spPr>
+          <a:xfrm>
+            <a:off x="9221724" y="4754880"/>
+            <a:ext cx="2235708" cy="438912"/>
+          </a:xfrm>
+          <a:prstGeom prst="rect">
+            <a:avLst/>
+          </a:prstGeom>
+          <a:noFill/>
+          <a:ln/>
+        </p:spPr>
+        <p:txBody>
+          <a:bodyPr wrap="square" lIns="0" tIns="0" rIns="0" bIns="0" rtlCol="0" anchor="ctr"/>
+          <a:lstStyle/>
+          <a:p>
+            <a:pPr indent="0" marL="0">
+              <a:buNone/>
+            </a:pPr>
+            <a:r>
+              <a:rPr lang="en-US" sz="3000" b="1" dirty="0">
+                <a:solidFill>
+                  <a:srgbClr val="0E6B4F"/>
+                </a:solidFill>
+                <a:latin typeface="Cambria" pitchFamily="34" charset="0"/>
+                <a:ea typeface="Cambria" pitchFamily="34" charset="-122"/>
+                <a:cs typeface="Cambria" pitchFamily="34" charset="-120"/>
+              </a:rPr>
+              <a:t>0</a:t>
+            </a:r>
+            <a:endParaRPr lang="en-US" sz="3000" dirty="0"/>
+          </a:p>
+        </p:txBody>
+      </p:sp>
+      <p:sp>
+        <p:nvSpPr>
+          <p:cNvPr id="26" name="Text 24"/>
+          <p:cNvSpPr txBox="1"/>
+          <p:nvPr/>
+        </p:nvSpPr>
+        <p:spPr>
+          <a:xfrm>
+            <a:off x="9221724" y="5175504"/>
+            <a:ext cx="2235708" cy="237744"/>
+          </a:xfrm>
+          <a:prstGeom prst="rect">
+            <a:avLst/>
+          </a:prstGeom>
+          <a:noFill/>
+          <a:ln/>
+        </p:spPr>
+        <p:txBody>
+          <a:bodyPr wrap="square" lIns="0" tIns="0" rIns="0" bIns="0" rtlCol="0" anchor="ctr"/>
+          <a:lstStyle/>
+          <a:p>
+            <a:pPr indent="0" marL="0">
+              <a:buNone/>
+            </a:pPr>
+            <a:r>
+              <a:rPr lang="en-US" sz="1250" b="1" dirty="0">
+                <a:solidFill>
+                  <a:srgbClr val="16232E"/>
+                </a:solidFill>
+                <a:latin typeface="Calibri" pitchFamily="34" charset="0"/>
+                <a:ea typeface="Calibri" pitchFamily="34" charset="-122"/>
+                <a:cs typeface="Calibri" pitchFamily="34" charset="-120"/>
+              </a:rPr>
+              <a:t>secrets committed</a:t>
+            </a:r>
+            <a:endParaRPr lang="en-US" sz="1250" dirty="0"/>
+          </a:p>
+        </p:txBody>
+      </p:sp>
+      <p:sp>
+        <p:nvSpPr>
+          <p:cNvPr id="27" name="Text 25"/>
+          <p:cNvSpPr txBox="1"/>
+          <p:nvPr/>
+        </p:nvSpPr>
+        <p:spPr>
+          <a:xfrm>
+            <a:off x="9221724" y="5422392"/>
+            <a:ext cx="2235708" cy="402336"/>
+          </a:xfrm>
+          <a:prstGeom prst="rect">
+            <a:avLst/>
+          </a:prstGeom>
+          <a:noFill/>
+          <a:ln/>
+        </p:spPr>
+        <p:txBody>
+          <a:bodyPr wrap="square" lIns="0" tIns="0" rIns="0" bIns="0" rtlCol="0" anchor="ctr"/>
+          <a:lstStyle/>
+          <a:p>
+            <a:pPr indent="0" marL="0">
+              <a:lnSpc>
+                <a:spcPts val="1200"/>
+              </a:lnSpc>
+              <a:buNone/>
+            </a:pPr>
+            <a:r>
+              <a:rPr lang="en-US" sz="1050" dirty="0">
+                <a:solidFill>
+                  <a:srgbClr val="5A6570"/>
+                </a:solidFill>
+                <a:latin typeface="Calibri" pitchFamily="34" charset="0"/>
+                <a:ea typeface="Calibri" pitchFamily="34" charset="-122"/>
+                <a:cs typeface="Calibri" pitchFamily="34" charset="-120"/>
+              </a:rPr>
+              <a:t>every credential read from the environment</a:t>
+            </a:r>
+            <a:endParaRPr lang="en-US" sz="1050" dirty="0"/>
+          </a:p>
+        </p:txBody>
+      </p:sp>
+      <p:sp>
+        <p:nvSpPr>
+          <p:cNvPr id="28" name="Text 26"/>
+          <p:cNvSpPr txBox="1"/>
+          <p:nvPr/>
+        </p:nvSpPr>
+        <p:spPr>
+          <a:xfrm>
+            <a:off x="502920" y="6327648"/>
+            <a:ext cx="11155680" cy="301752"/>
+          </a:xfrm>
+          <a:prstGeom prst="rect">
+            <a:avLst/>
+          </a:prstGeom>
+          <a:noFill/>
+          <a:ln/>
+        </p:spPr>
+        <p:txBody>
+          <a:bodyPr wrap="square" lIns="0" tIns="0" rIns="0" bIns="0" rtlCol="0" anchor="t"/>
+          <a:lstStyle/>
+          <a:p>
+            <a:pPr indent="0" marL="0">
+              <a:buNone/>
+            </a:pPr>
+            <a:r>
+              <a:rPr lang="en-US" sz="1050" i="1" dirty="0">
+                <a:solidFill>
+                  <a:srgbClr val="8A949C"/>
+                </a:solidFill>
+                <a:latin typeface="Calibri" pitchFamily="34" charset="0"/>
+                <a:ea typeface="Calibri" pitchFamily="34" charset="-122"/>
+                <a:cs typeface="Calibri" pitchFamily="34" charset="-120"/>
+              </a:rPr>
+              <a:t>The API is on a free tier that sleeps when idle; a scheduled request every ten minutes keeps it warm, so the link responds immediately</a:t>
+            </a:r>
+            <a:endParaRPr lang="en-US" sz="1050" dirty="0"/>
+          </a:p>
+        </p:txBody>
+      </p:sp>
+    </p:spTree>
+  </p:cSld>
+  <p:clrMapOvr>
+    <a:masterClrMapping/>
+  </p:clrMapOvr>
+</p:sld>
+</file>
+
+<file path=ppt/slides/slide33.xml><?xml version="1.0" encoding="utf-8"?>
+<p:sld xmlns:a="http://schemas.openxmlformats.org/drawingml/2006/main" xmlns:r="http://schemas.openxmlformats.org/officeDocument/2006/relationships" xmlns:p="http://schemas.openxmlformats.org/presentationml/2006/main">
+  <p:cSld name="Slide 33">
+    <p:bg>
+      <p:bgPr>
+        <a:solidFill>
           <a:srgbClr val="16232E"/>
         </a:solidFill>
       </p:bgPr>
@@ -24271,7 +25528,7 @@
         </p:nvSpPr>
         <p:spPr>
           <a:xfrm>
-            <a:off x="502920" y="5212080"/>
+            <a:off x="502920" y="4974336"/>
             <a:ext cx="2926080" cy="502920"/>
           </a:xfrm>
           <a:prstGeom prst="roundRect">
@@ -24293,7 +25550,7 @@
         </p:nvSpPr>
         <p:spPr>
           <a:xfrm>
-            <a:off x="502920" y="5212080"/>
+            <a:off x="502920" y="4974336"/>
             <a:ext cx="2926080" cy="502920"/>
           </a:xfrm>
           <a:prstGeom prst="rect">
@@ -24332,7 +25589,7 @@
         </p:nvSpPr>
         <p:spPr>
           <a:xfrm>
-            <a:off x="3657600" y="5212080"/>
+            <a:off x="3657600" y="4974336"/>
             <a:ext cx="2926080" cy="502920"/>
           </a:xfrm>
           <a:prstGeom prst="roundRect">
@@ -24354,7 +25611,7 @@
         </p:nvSpPr>
         <p:spPr>
           <a:xfrm>
-            <a:off x="3657600" y="5212080"/>
+            <a:off x="3657600" y="4974336"/>
             <a:ext cx="2926080" cy="502920"/>
           </a:xfrm>
           <a:prstGeom prst="rect">
@@ -24393,7 +25650,7 @@
         </p:nvSpPr>
         <p:spPr>
           <a:xfrm>
-            <a:off x="6812280" y="5212080"/>
+            <a:off x="6812280" y="4974336"/>
             <a:ext cx="2926080" cy="502920"/>
           </a:xfrm>
           <a:prstGeom prst="roundRect">
@@ -24415,7 +25672,7 @@
         </p:nvSpPr>
         <p:spPr>
           <a:xfrm>
-            <a:off x="6812280" y="5212080"/>
+            <a:off x="6812280" y="4974336"/>
             <a:ext cx="2926080" cy="502920"/>
           </a:xfrm>
           <a:prstGeom prst="rect">
@@ -24443,6 +25700,109 @@
               <a:t>The applicant gets a plan</a:t>
             </a:r>
             <a:endParaRPr lang="en-US" sz="1300" dirty="0"/>
+          </a:p>
+        </p:txBody>
+      </p:sp>
+      <p:sp>
+        <p:nvSpPr>
+          <p:cNvPr id="25" name="Shape 23"/>
+          <p:cNvSpPr/>
+          <p:nvPr/>
+        </p:nvSpPr>
+        <p:spPr>
+          <a:xfrm>
+            <a:off x="502920" y="5650992"/>
+            <a:ext cx="11155680" cy="658368"/>
+          </a:xfrm>
+          <a:prstGeom prst="roundRect">
+            <a:avLst>
+              <a:gd name="adj" fmla="val 13889"/>
+            </a:avLst>
+          </a:prstGeom>
+          <a:solidFill>
+            <a:srgbClr val="1C2F3D"/>
+          </a:solidFill>
+          <a:ln/>
+        </p:spPr>
+      </p:sp>
+      <p:sp>
+        <p:nvSpPr>
+          <p:cNvPr id="26" name="Text 24"/>
+          <p:cNvSpPr txBox="1"/>
+          <p:nvPr/>
+        </p:nvSpPr>
+        <p:spPr>
+          <a:xfrm>
+            <a:off x="777240" y="5650992"/>
+            <a:ext cx="10607040" cy="658368"/>
+          </a:xfrm>
+          <a:prstGeom prst="rect">
+            <a:avLst/>
+          </a:prstGeom>
+          <a:noFill/>
+          <a:ln/>
+        </p:spPr>
+        <p:txBody>
+          <a:bodyPr wrap="square" lIns="0" tIns="0" rIns="0" bIns="0" rtlCol="0" anchor="ctr"/>
+          <a:lstStyle/>
+          <a:p>
+            <a:pPr indent="0" marL="0">
+              <a:buNone/>
+            </a:pPr>
+            <a:r>
+              <a:rPr lang="en-US" sz="1100" b="1" spc="150" kern="0" dirty="0">
+                <a:solidFill>
+                  <a:srgbClr val="8FD7B8"/>
+                </a:solidFill>
+                <a:latin typeface="Calibri" pitchFamily="34" charset="0"/>
+                <a:ea typeface="Calibri" pitchFamily="34" charset="-122"/>
+                <a:cs typeface="Calibri" pitchFamily="34" charset="-120"/>
+              </a:rPr>
+              <a:t>LIVE  </a:t>
+            </a:r>
+            <a:pPr indent="0" marL="0">
+              <a:buNone/>
+            </a:pPr>
+            <a:r>
+              <a:rPr lang="en-US" sz="1450" b="1" dirty="0">
+                <a:solidFill>
+                  <a:srgbClr val="FFFFFF"/>
+                </a:solidFill>
+                <a:latin typeface="Calibri" pitchFamily="34" charset="0"/>
+                <a:ea typeface="Calibri" pitchFamily="34" charset="-122"/>
+                <a:cs typeface="Calibri" pitchFamily="34" charset="-120"/>
+              </a:rPr>
+              <a:t>pratyaya-beta.vercel.app</a:t>
+            </a:r>
+            <a:pPr indent="0" marL="0">
+              <a:buNone/>
+            </a:pPr>
+            <a:r>
+              <a:rPr lang="en-US" sz="1100" b="1" spc="150" kern="0" dirty="0">
+                <a:solidFill>
+                  <a:srgbClr val="8FD7B8"/>
+                </a:solidFill>
+                <a:latin typeface="Calibri" pitchFamily="34" charset="0"/>
+                <a:ea typeface="Calibri" pitchFamily="34" charset="-122"/>
+                <a:cs typeface="Calibri" pitchFamily="34" charset="-120"/>
+              </a:rPr>
+              <a:t>        CODE  </a:t>
+            </a:r>
+            <a:pPr indent="0" marL="0">
+              <a:buNone/>
+            </a:pPr>
+            <a:r>
+              <a:rPr lang="en-US" sz="1450" b="1" dirty="0">
+                <a:solidFill>
+                  <a:srgbClr val="FFFFFF"/>
+                </a:solidFill>
+                <a:latin typeface="Calibri" pitchFamily="34" charset="0"/>
+                <a:ea typeface="Calibri" pitchFamily="34" charset="-122"/>
+                <a:cs typeface="Calibri" pitchFamily="34" charset="-120"/>
+              </a:rPr>
+              <a:t>github.com/Nishantttt-ui/pratyaya</a:t>
+            </a:r>
+            <a:endParaRPr lang="en-US" sz="1100" dirty="0"/>
           </a:p>
         </p:txBody>
       </p:sp>

</xml_diff>

<commit_message>
Make the links in the deck clickable
The URLs were rendered as plain text, so a reader would have had to retype
them. They are now real PowerPoint hyperlinks, underlined and carrying tooltips:
the running application and the repository on the cover, on the slide that
points at both, and on the closing slide, plus the live health endpoint on the
architecture slide.

Verified by reading the hyperlink targets back out of the generated file rather
than trusting that they were written.

Co-Authored-By: Claude Opus 5 <noreply@anthropic.com>
</commit_message>
<xml_diff>
--- a/docs/Pratyaya-Synchrony-Hackathon.pptx
+++ b/docs/Pratyaya-Synchrony-Hackathon.pptx
@@ -4087,13 +4087,20 @@
               <a:buNone/>
             </a:pPr>
             <a:r>
-              <a:rPr lang="en-US" sz="1500" b="1" dirty="0">
+              <a:rPr lang="en-US" sz="1500" b="1" u="sng" dirty="0">
                 <a:solidFill>
                   <a:srgbClr val="FFFFFF"/>
                 </a:solidFill>
                 <a:latin typeface="Calibri" pitchFamily="34" charset="0"/>
                 <a:ea typeface="Calibri" pitchFamily="34" charset="-122"/>
                 <a:cs typeface="Calibri" pitchFamily="34" charset="-120"/>
+                <a:hlinkClick r:id="rId1" invalidUrl="" action="" tgtFrame="" tooltip="Open the running application" history="1" highlightClick="0" endSnd="0">
+                  <a:extLst>
+                    <a:ext uri="{A12FA001-AC4F-418D-AE19-62706E023703}">
+                      <ahyp:hlinkClr xmlns:ahyp="http://schemas.microsoft.com/office/drawing/2018/hyperlinkcolor" val="tx"/>
+                    </a:ext>
+                  </a:extLst>
+                </a:hlinkClick>
               </a:rPr>
               <a:t>pratyaya-beta.vercel.app</a:t>
             </a:r>
@@ -4115,13 +4122,20 @@
               <a:buNone/>
             </a:pPr>
             <a:r>
-              <a:rPr lang="en-US" sz="1500" b="1" dirty="0">
+              <a:rPr lang="en-US" sz="1500" b="1" u="sng" dirty="0">
                 <a:solidFill>
                   <a:srgbClr val="FFFFFF"/>
                 </a:solidFill>
                 <a:latin typeface="Calibri" pitchFamily="34" charset="0"/>
                 <a:ea typeface="Calibri" pitchFamily="34" charset="-122"/>
                 <a:cs typeface="Calibri" pitchFamily="34" charset="-120"/>
+                <a:hlinkClick r:id="rId2" invalidUrl="" action="" tgtFrame="" tooltip="Open the source repository" history="1" highlightClick="0" endSnd="0">
+                  <a:extLst>
+                    <a:ext uri="{A12FA001-AC4F-418D-AE19-62706E023703}">
+                      <ahyp:hlinkClr xmlns:ahyp="http://schemas.microsoft.com/office/drawing/2018/hyperlinkcolor" val="tx"/>
+                    </a:ext>
+                  </a:extLst>
+                </a:hlinkClick>
               </a:rPr>
               <a:t>github.com/Nishantttt-ui/pratyaya</a:t>
             </a:r>
@@ -23966,13 +23980,20 @@
               <a:buNone/>
             </a:pPr>
             <a:r>
-              <a:rPr lang="en-US" sz="3000" b="1" dirty="0">
+              <a:rPr lang="en-US" sz="3000" b="1" u="sng" dirty="0">
                 <a:solidFill>
                   <a:srgbClr val="16232E"/>
                 </a:solidFill>
                 <a:latin typeface="Cambria" pitchFamily="34" charset="0"/>
                 <a:ea typeface="Cambria" pitchFamily="34" charset="-122"/>
                 <a:cs typeface="Cambria" pitchFamily="34" charset="-120"/>
+                <a:hlinkClick r:id="rId1" invalidUrl="" action="" tgtFrame="" tooltip="Open the running application" history="1" highlightClick="0" endSnd="0">
+                  <a:extLst>
+                    <a:ext uri="{A12FA001-AC4F-418D-AE19-62706E023703}">
+                      <ahyp:hlinkClr xmlns:ahyp="http://schemas.microsoft.com/office/drawing/2018/hyperlinkcolor" val="tx"/>
+                    </a:ext>
+                  </a:extLst>
+                </a:hlinkClick>
               </a:rPr>
               <a:t>pratyaya-beta.vercel.app</a:t>
             </a:r>
@@ -24112,13 +24133,20 @@
               <a:buNone/>
             </a:pPr>
             <a:r>
-              <a:rPr lang="en-US" sz="3000" b="1" dirty="0">
+              <a:rPr lang="en-US" sz="3000" b="1" u="sng" dirty="0">
                 <a:solidFill>
                   <a:srgbClr val="FFFFFF"/>
                 </a:solidFill>
                 <a:latin typeface="Cambria" pitchFamily="34" charset="0"/>
                 <a:ea typeface="Cambria" pitchFamily="34" charset="-122"/>
                 <a:cs typeface="Cambria" pitchFamily="34" charset="-120"/>
+                <a:hlinkClick r:id="rId2" invalidUrl="" action="" tgtFrame="" tooltip="Open the source repository" history="1" highlightClick="0" endSnd="0">
+                  <a:extLst>
+                    <a:ext uri="{A12FA001-AC4F-418D-AE19-62706E023703}">
+                      <ahyp:hlinkClr xmlns:ahyp="http://schemas.microsoft.com/office/drawing/2018/hyperlinkcolor" val="tx"/>
+                    </a:ext>
+                  </a:extLst>
+                </a:hlinkClick>
               </a:rPr>
               <a:t>github.com/Nishantttt-ui/pratyaya</a:t>
             </a:r>
@@ -25764,13 +25792,20 @@
               <a:buNone/>
             </a:pPr>
             <a:r>
-              <a:rPr lang="en-US" sz="1450" b="1" dirty="0">
+              <a:rPr lang="en-US" sz="1450" b="1" u="sng" dirty="0">
                 <a:solidFill>
                   <a:srgbClr val="FFFFFF"/>
                 </a:solidFill>
                 <a:latin typeface="Calibri" pitchFamily="34" charset="0"/>
                 <a:ea typeface="Calibri" pitchFamily="34" charset="-122"/>
                 <a:cs typeface="Calibri" pitchFamily="34" charset="-120"/>
+                <a:hlinkClick r:id="rId1" invalidUrl="" action="" tgtFrame="" tooltip="Open the running application" history="1" highlightClick="0" endSnd="0">
+                  <a:extLst>
+                    <a:ext uri="{A12FA001-AC4F-418D-AE19-62706E023703}">
+                      <ahyp:hlinkClr xmlns:ahyp="http://schemas.microsoft.com/office/drawing/2018/hyperlinkcolor" val="tx"/>
+                    </a:ext>
+                  </a:extLst>
+                </a:hlinkClick>
               </a:rPr>
               <a:t>pratyaya-beta.vercel.app</a:t>
             </a:r>
@@ -25792,13 +25827,20 @@
               <a:buNone/>
             </a:pPr>
             <a:r>
-              <a:rPr lang="en-US" sz="1450" b="1" dirty="0">
+              <a:rPr lang="en-US" sz="1450" b="1" u="sng" dirty="0">
                 <a:solidFill>
                   <a:srgbClr val="FFFFFF"/>
                 </a:solidFill>
                 <a:latin typeface="Calibri" pitchFamily="34" charset="0"/>
                 <a:ea typeface="Calibri" pitchFamily="34" charset="-122"/>
                 <a:cs typeface="Calibri" pitchFamily="34" charset="-120"/>
+                <a:hlinkClick r:id="rId2" invalidUrl="" action="" tgtFrame="" tooltip="Open the source repository" history="1" highlightClick="0" endSnd="0">
+                  <a:extLst>
+                    <a:ext uri="{A12FA001-AC4F-418D-AE19-62706E023703}">
+                      <ahyp:hlinkClr xmlns:ahyp="http://schemas.microsoft.com/office/drawing/2018/hyperlinkcolor" val="tx"/>
+                    </a:ext>
+                  </a:extLst>
+                </a:hlinkClick>
               </a:rPr>
               <a:t>github.com/Nishantttt-ui/pratyaya</a:t>
             </a:r>
@@ -29104,7 +29146,42 @@
                 <a:ea typeface="Calibri" pitchFamily="34" charset="-122"/>
                 <a:cs typeface="Calibri" pitchFamily="34" charset="-120"/>
               </a:rPr>
-              <a:t>Every layer shown is running: /health reports model ready, 37 provisions, vector_store pgvector, llm_provider gemini</a:t>
+              <a:t>Every layer shown is running: </a:t>
+            </a:r>
+            <a:pPr indent="0" marL="0">
+              <a:buNone/>
+            </a:pPr>
+            <a:r>
+              <a:rPr lang="en-US" sz="1050" i="1" u="sng" dirty="0">
+                <a:solidFill>
+                  <a:srgbClr val="8A949C"/>
+                </a:solidFill>
+                <a:latin typeface="Calibri" pitchFamily="34" charset="0"/>
+                <a:ea typeface="Calibri" pitchFamily="34" charset="-122"/>
+                <a:cs typeface="Calibri" pitchFamily="34" charset="-120"/>
+                <a:hlinkClick r:id="rId1" invalidUrl="" action="" tgtFrame="" tooltip="Live component readiness" history="1" highlightClick="0" endSnd="0">
+                  <a:extLst>
+                    <a:ext uri="{A12FA001-AC4F-418D-AE19-62706E023703}">
+                      <ahyp:hlinkClr xmlns:ahyp="http://schemas.microsoft.com/office/drawing/2018/hyperlinkcolor" val="tx"/>
+                    </a:ext>
+                  </a:extLst>
+                </a:hlinkClick>
+              </a:rPr>
+              <a:t>pratyaya-api.onrender.com/health</a:t>
+            </a:r>
+            <a:pPr indent="0" marL="0">
+              <a:buNone/>
+            </a:pPr>
+            <a:r>
+              <a:rPr lang="en-US" sz="1050" i="1" dirty="0">
+                <a:solidFill>
+                  <a:srgbClr val="8A949C"/>
+                </a:solidFill>
+                <a:latin typeface="Calibri" pitchFamily="34" charset="0"/>
+                <a:ea typeface="Calibri" pitchFamily="34" charset="-122"/>
+                <a:cs typeface="Calibri" pitchFamily="34" charset="-120"/>
+              </a:rPr>
+              <a:t> reports model ready, 37 provisions, vector_store pgvector, llm_provider gemini</a:t>
             </a:r>
             <a:endParaRPr lang="en-US" sz="1050" dirty="0"/>
           </a:p>

</xml_diff>

<commit_message>
Size the limitations text to its box
The two response columns needed 1.22in in a 1.04in box. Measured, resized,
re-verified.

Co-Authored-By: Claude Opus 5 <noreply@anthropic.com>
</commit_message>
<xml_diff>
--- a/docs/Pratyaya-Synchrony-Hackathon.pptx
+++ b/docs/Pratyaya-Synchrony-Hackathon.pptx
@@ -23483,8 +23483,8 @@
         </p:nvSpPr>
         <p:spPr>
           <a:xfrm>
-            <a:off x="1362456" y="2414016"/>
-            <a:ext cx="4892040" cy="950976"/>
+            <a:off x="1362456" y="2395728"/>
+            <a:ext cx="4892040" cy="1005840"/>
           </a:xfrm>
           <a:prstGeom prst="rect">
             <a:avLst/>
@@ -23498,12 +23498,12 @@
           <a:p>
             <a:pPr indent="0" marL="0">
               <a:lnSpc>
-                <a:spcPts val="1500"/>
+                <a:spcPts val="1400"/>
               </a:lnSpc>
               <a:buNone/>
             </a:pPr>
             <a:r>
-              <a:rPr lang="en-US" sz="1200" dirty="0">
+              <a:rPr lang="en-US" sz="1150" dirty="0">
                 <a:solidFill>
                   <a:srgbClr val="3C4E58"/>
                 </a:solidFill>
@@ -23513,7 +23513,7 @@
               </a:rPr>
               <a:t>No public dataset joins Account Aggregator-style alternative data to realised loan outcomes for Indian borrowers. That data is personal financial information and is not published, so the alternative was not real data but a foreign dataset relabelled.</a:t>
             </a:r>
-            <a:endParaRPr lang="en-US" sz="1200" dirty="0"/>
+            <a:endParaRPr lang="en-US" sz="1150" dirty="0"/>
           </a:p>
         </p:txBody>
       </p:sp>
@@ -23564,8 +23564,8 @@
         </p:nvSpPr>
         <p:spPr>
           <a:xfrm>
-            <a:off x="6528816" y="2414016"/>
-            <a:ext cx="4617720" cy="950976"/>
+            <a:off x="6528816" y="2395728"/>
+            <a:ext cx="4617720" cy="1005840"/>
           </a:xfrm>
           <a:prstGeom prst="rect">
             <a:avLst/>
@@ -23579,12 +23579,12 @@
           <a:p>
             <a:pPr indent="0" marL="0">
               <a:lnSpc>
-                <a:spcPts val="1500"/>
+                <a:spcPts val="1400"/>
               </a:lnSpc>
               <a:buNone/>
             </a:pPr>
             <a:r>
-              <a:rPr lang="en-US" sz="1200" dirty="0">
+              <a:rPr lang="en-US" sz="1150" dirty="0">
                 <a:solidFill>
                   <a:srgbClr val="16232E"/>
                 </a:solidFill>
@@ -23594,7 +23594,7 @@
               </a:rPr>
               <a:t>The same pipeline was run over 30,000 real defaults. The accuracy claim replicated: AUC 0.7711 → 0.7829, bad rate down. Our synthetic difficulty sits between two real datasets, and the fairness claim's precondition is stated precisely enough that a lender could test it against their own book in an afternoon.</a:t>
             </a:r>
-            <a:endParaRPr lang="en-US" sz="1200" dirty="0"/>
+            <a:endParaRPr lang="en-US" sz="1150" dirty="0"/>
           </a:p>
         </p:txBody>
       </p:sp>
@@ -23777,8 +23777,8 @@
         </p:nvSpPr>
         <p:spPr>
           <a:xfrm>
-            <a:off x="1362456" y="4535424"/>
-            <a:ext cx="4892040" cy="950976"/>
+            <a:off x="1362456" y="4517136"/>
+            <a:ext cx="4892040" cy="1005840"/>
           </a:xfrm>
           <a:prstGeom prst="rect">
             <a:avLst/>
@@ -23792,12 +23792,12 @@
           <a:p>
             <a:pPr indent="0" marL="0">
               <a:lnSpc>
-                <a:spcPts val="1500"/>
+                <a:spcPts val="1400"/>
               </a:lnSpc>
               <a:buNone/>
             </a:pPr>
             <a:r>
-              <a:rPr lang="en-US" sz="1200" dirty="0">
+              <a:rPr lang="en-US" sz="1150" dirty="0">
                 <a:solidFill>
                   <a:srgbClr val="3C4E58"/>
                 </a:solidFill>
@@ -23807,7 +23807,7 @@
               </a:rPr>
               <a:t>Every provision is a plain-language summary carrying a citation to the instrument it summarises, labelled as such in the corpus README, the model card and this deck.</a:t>
             </a:r>
-            <a:endParaRPr lang="en-US" sz="1200" dirty="0"/>
+            <a:endParaRPr lang="en-US" sz="1150" dirty="0"/>
           </a:p>
         </p:txBody>
       </p:sp>
@@ -23858,8 +23858,8 @@
         </p:nvSpPr>
         <p:spPr>
           <a:xfrm>
-            <a:off x="6528816" y="4535424"/>
-            <a:ext cx="4617720" cy="950976"/>
+            <a:off x="6528816" y="4517136"/>
+            <a:ext cx="4617720" cy="1005840"/>
           </a:xfrm>
           <a:prstGeom prst="rect">
             <a:avLst/>
@@ -23873,12 +23873,12 @@
           <a:p>
             <a:pPr indent="0" marL="0">
               <a:lnSpc>
-                <a:spcPts val="1500"/>
+                <a:spcPts val="1400"/>
               </a:lnSpc>
               <a:buNone/>
             </a:pPr>
             <a:r>
-              <a:rPr lang="en-US" sz="1200" dirty="0">
+              <a:rPr lang="en-US" sz="1150" dirty="0">
                 <a:solidFill>
                   <a:srgbClr val="16232E"/>
                 </a:solidFill>
@@ -23888,7 +23888,7 @@
               </a:rPr>
               <a:t>That was the deliberate choice, not a shortcut. Seeding a retrieval corpus with invented quotations from RBI circulars would commit precisely the hallucination this architecture exists to prevent, and would not survive a reader who knows the regulations. Production ingests the official texts; the retrieval, chunking, citation and audit machinery is unchanged.</a:t>
             </a:r>
-            <a:endParaRPr lang="en-US" sz="1200" dirty="0"/>
+            <a:endParaRPr lang="en-US" sz="1150" dirty="0"/>
           </a:p>
         </p:txBody>
       </p:sp>

</xml_diff>

<commit_message>
Put the demo credentials next to the links wherever they appear
The cover and the closing slide carried both URLs but no way to sign in, so a
reader clicking from either would have reached a login screen with nothing to
type. The credentials were only on the slide that points at the system, which
is the one a reader might never reach.

Both slides now show the two demo accounts beneath the links: the underwriter
for the full decision, the applicant for what a borrower receives. Checking both
is the fastest way to see the role projection, which is the hardest part of this
to describe and the easiest to look at.

Co-Authored-By: Claude Opus 5 <noreply@anthropic.com>
</commit_message>
<xml_diff>
--- a/docs/Pratyaya-Synchrony-Hackathon.pptx
+++ b/docs/Pratyaya-Synchrony-Hackathon.pptx
@@ -4034,12 +4034,12 @@
         </p:nvSpPr>
         <p:spPr>
           <a:xfrm>
-            <a:off x="502920" y="4617720"/>
-            <a:ext cx="11155680" cy="786384"/>
+            <a:off x="502920" y="4517136"/>
+            <a:ext cx="11155680" cy="969264"/>
           </a:xfrm>
           <a:prstGeom prst="roundRect">
             <a:avLst>
-              <a:gd name="adj" fmla="val 11628"/>
+              <a:gd name="adj" fmla="val 9434"/>
             </a:avLst>
           </a:prstGeom>
           <a:solidFill>
@@ -4056,8 +4056,89 @@
         </p:nvSpPr>
         <p:spPr>
           <a:xfrm>
-            <a:off x="777240" y="4617720"/>
-            <a:ext cx="10607040" cy="786384"/>
+            <a:off x="777240" y="5047488"/>
+            <a:ext cx="10607040" cy="329184"/>
+          </a:xfrm>
+          <a:prstGeom prst="rect">
+            <a:avLst/>
+          </a:prstGeom>
+          <a:noFill/>
+          <a:ln/>
+        </p:spPr>
+        <p:txBody>
+          <a:bodyPr wrap="square" lIns="0" tIns="0" rIns="0" bIns="0" rtlCol="0" anchor="ctr"/>
+          <a:lstStyle/>
+          <a:p>
+            <a:pPr indent="0" marL="0">
+              <a:buNone/>
+            </a:pPr>
+            <a:r>
+              <a:rPr lang="en-US" sz="1000" b="1" spc="150" kern="0" dirty="0">
+                <a:solidFill>
+                  <a:srgbClr val="8FD7B8"/>
+                </a:solidFill>
+                <a:latin typeface="Calibri" pitchFamily="34" charset="0"/>
+                <a:ea typeface="Calibri" pitchFamily="34" charset="-122"/>
+                <a:cs typeface="Calibri" pitchFamily="34" charset="-120"/>
+              </a:rPr>
+              <a:t>SIGN IN  </a:t>
+            </a:r>
+            <a:pPr indent="0" marL="0">
+              <a:buNone/>
+            </a:pPr>
+            <a:r>
+              <a:rPr lang="en-US" sz="1200" dirty="0">
+                <a:solidFill>
+                  <a:srgbClr val="C9D4DD"/>
+                </a:solidFill>
+                <a:latin typeface="Calibri" pitchFamily="34" charset="0"/>
+                <a:ea typeface="Calibri" pitchFamily="34" charset="-122"/>
+                <a:cs typeface="Calibri" pitchFamily="34" charset="-120"/>
+              </a:rPr>
+              <a:t>underwriter / demo-underwriter-pw</a:t>
+            </a:r>
+            <a:pPr indent="0" marL="0">
+              <a:buNone/>
+            </a:pPr>
+            <a:r>
+              <a:rPr lang="en-US" sz="1200" dirty="0">
+                <a:solidFill>
+                  <a:srgbClr val="5A6E7C"/>
+                </a:solidFill>
+                <a:latin typeface="Calibri" pitchFamily="34" charset="0"/>
+                <a:ea typeface="Calibri" pitchFamily="34" charset="-122"/>
+                <a:cs typeface="Calibri" pitchFamily="34" charset="-120"/>
+              </a:rPr>
+              <a:t>   ·   </a:t>
+            </a:r>
+            <a:pPr indent="0" marL="0">
+              <a:buNone/>
+            </a:pPr>
+            <a:r>
+              <a:rPr lang="en-US" sz="1200" dirty="0">
+                <a:solidFill>
+                  <a:srgbClr val="C9D4DD"/>
+                </a:solidFill>
+                <a:latin typeface="Calibri" pitchFamily="34" charset="0"/>
+                <a:ea typeface="Calibri" pitchFamily="34" charset="-122"/>
+                <a:cs typeface="Calibri" pitchFamily="34" charset="-120"/>
+              </a:rPr>
+              <a:t>applicant / demo-applicant-pw</a:t>
+            </a:r>
+            <a:endParaRPr lang="en-US" sz="1000" dirty="0"/>
+          </a:p>
+        </p:txBody>
+      </p:sp>
+      <p:sp>
+        <p:nvSpPr>
+          <p:cNvPr id="13" name="Text 11"/>
+          <p:cNvSpPr txBox="1"/>
+          <p:nvPr/>
+        </p:nvSpPr>
+        <p:spPr>
+          <a:xfrm>
+            <a:off x="777240" y="4626864"/>
+            <a:ext cx="10607040" cy="402336"/>
           </a:xfrm>
           <a:prstGeom prst="rect">
             <a:avLst/>
@@ -4145,13 +4226,13 @@
       </p:sp>
       <p:sp>
         <p:nvSpPr>
-          <p:cNvPr id="13" name="Shape 11"/>
+          <p:cNvPr id="14" name="Shape 12"/>
           <p:cNvSpPr/>
           <p:nvPr/>
         </p:nvSpPr>
         <p:spPr>
           <a:xfrm>
-            <a:off x="502920" y="5596128"/>
+            <a:off x="502920" y="5669280"/>
             <a:ext cx="3840480" cy="0"/>
           </a:xfrm>
           <a:prstGeom prst="line">
@@ -4168,14 +4249,14 @@
       </p:sp>
       <p:sp>
         <p:nvSpPr>
-          <p:cNvPr id="14" name="Text 12"/>
-          <p:cNvSpPr txBox="1"/>
-          <p:nvPr/>
-        </p:nvSpPr>
-        <p:spPr>
-          <a:xfrm>
-            <a:off x="502920" y="5760720"/>
-            <a:ext cx="9601200" cy="731520"/>
+          <p:cNvPr id="15" name="Text 13"/>
+          <p:cNvSpPr txBox="1"/>
+          <p:nvPr/>
+        </p:nvSpPr>
+        <p:spPr>
+          <a:xfrm>
+            <a:off x="502920" y="5815584"/>
+            <a:ext cx="9601200" cy="694944"/>
           </a:xfrm>
           <a:prstGeom prst="rect">
             <a:avLst/>
@@ -4189,12 +4270,12 @@
           <a:p>
             <a:pPr indent="0" marL="0">
               <a:lnSpc>
-                <a:spcPts val="1800"/>
+                <a:spcPts val="1700"/>
               </a:lnSpc>
               <a:buNone/>
             </a:pPr>
             <a:r>
-              <a:rPr lang="en-US" sz="1250" i="1" dirty="0">
+              <a:rPr lang="en-US" sz="1200" i="1" dirty="0">
                 <a:solidFill>
                   <a:srgbClr val="FFFFFF"/>
                 </a:solidFill>
@@ -4206,12 +4287,12 @@
             </a:r>
             <a:pPr indent="0" marL="0">
               <a:lnSpc>
-                <a:spcPts val="1800"/>
+                <a:spcPts val="1700"/>
               </a:lnSpc>
               <a:buNone/>
             </a:pPr>
             <a:r>
-              <a:rPr lang="en-US" sz="1250" dirty="0">
+              <a:rPr lang="en-US" sz="1200" dirty="0">
                 <a:solidFill>
                   <a:srgbClr val="93A0AA"/>
                 </a:solidFill>
@@ -4223,12 +4304,12 @@
             </a:r>
             <a:pPr indent="0" marL="0">
               <a:lnSpc>
-                <a:spcPts val="1800"/>
+                <a:spcPts val="1700"/>
               </a:lnSpc>
               <a:buNone/>
             </a:pPr>
             <a:r>
-              <a:rPr lang="en-US" sz="1250" i="1" dirty="0">
+              <a:rPr lang="en-US" sz="1200" i="1" dirty="0">
                 <a:solidFill>
                   <a:srgbClr val="FFFFFF"/>
                 </a:solidFill>
@@ -4240,12 +4321,12 @@
             </a:r>
             <a:pPr indent="0" marL="0">
               <a:lnSpc>
-                <a:spcPts val="1800"/>
+                <a:spcPts val="1700"/>
               </a:lnSpc>
               <a:buNone/>
             </a:pPr>
             <a:r>
-              <a:rPr lang="en-US" sz="1250" dirty="0">
+              <a:rPr lang="en-US" sz="1200" dirty="0">
                 <a:solidFill>
                   <a:srgbClr val="93A0AA"/>
                 </a:solidFill>
@@ -4257,12 +4338,12 @@
             </a:r>
             <a:pPr indent="0" marL="0">
               <a:lnSpc>
-                <a:spcPts val="1800"/>
+                <a:spcPts val="1700"/>
               </a:lnSpc>
               <a:buNone/>
             </a:pPr>
             <a:r>
-              <a:rPr lang="en-US" sz="1250" i="1" dirty="0">
+              <a:rPr lang="en-US" sz="1200" i="1" dirty="0">
                 <a:solidFill>
                   <a:srgbClr val="FFFFFF"/>
                 </a:solidFill>
@@ -4274,12 +4355,12 @@
             </a:r>
             <a:pPr indent="0" marL="0">
               <a:lnSpc>
-                <a:spcPts val="1800"/>
+                <a:spcPts val="1700"/>
               </a:lnSpc>
               <a:buNone/>
             </a:pPr>
             <a:r>
-              <a:rPr lang="en-US" sz="1250" dirty="0">
+              <a:rPr lang="en-US" sz="1200" dirty="0">
                 <a:solidFill>
                   <a:srgbClr val="93A0AA"/>
                 </a:solidFill>
@@ -4289,17 +4370,17 @@
               </a:rPr>
               <a:t>, to believe.</a:t>
             </a:r>
-            <a:endParaRPr lang="en-US" sz="1250" dirty="0"/>
+            <a:endParaRPr lang="en-US" sz="1200" dirty="0"/>
           </a:p>
           <a:p>
             <a:pPr indent="0" marL="0">
               <a:lnSpc>
-                <a:spcPts val="1800"/>
+                <a:spcPts val="1700"/>
               </a:lnSpc>
               <a:buNone/>
             </a:pPr>
             <a:r>
-              <a:rPr lang="en-US" sz="1250" dirty="0">
+              <a:rPr lang="en-US" sz="1200" dirty="0">
                 <a:solidFill>
                   <a:srgbClr val="93A0AA"/>
                 </a:solidFill>
@@ -4309,7 +4390,7 @@
               </a:rPr>
               <a:t>Both name the same thing: a lender's belief that a borrower will repay.</a:t>
             </a:r>
-            <a:endParaRPr lang="en-US" sz="1250" dirty="0"/>
+            <a:endParaRPr lang="en-US" sz="1200" dirty="0"/>
           </a:p>
         </p:txBody>
       </p:sp>
@@ -25750,7 +25831,7 @@
         </p:nvSpPr>
         <p:spPr>
           <a:xfrm>
-            <a:off x="502920" y="4974336"/>
+            <a:off x="502920" y="4919472"/>
             <a:ext cx="2926080" cy="502920"/>
           </a:xfrm>
           <a:prstGeom prst="roundRect">
@@ -25772,7 +25853,7 @@
         </p:nvSpPr>
         <p:spPr>
           <a:xfrm>
-            <a:off x="502920" y="4974336"/>
+            <a:off x="502920" y="4919472"/>
             <a:ext cx="2926080" cy="502920"/>
           </a:xfrm>
           <a:prstGeom prst="rect">
@@ -25811,7 +25892,7 @@
         </p:nvSpPr>
         <p:spPr>
           <a:xfrm>
-            <a:off x="3657600" y="4974336"/>
+            <a:off x="3657600" y="4919472"/>
             <a:ext cx="2926080" cy="502920"/>
           </a:xfrm>
           <a:prstGeom prst="roundRect">
@@ -25833,7 +25914,7 @@
         </p:nvSpPr>
         <p:spPr>
           <a:xfrm>
-            <a:off x="3657600" y="4974336"/>
+            <a:off x="3657600" y="4919472"/>
             <a:ext cx="2926080" cy="502920"/>
           </a:xfrm>
           <a:prstGeom prst="rect">
@@ -25872,7 +25953,7 @@
         </p:nvSpPr>
         <p:spPr>
           <a:xfrm>
-            <a:off x="6812280" y="4974336"/>
+            <a:off x="6812280" y="4919472"/>
             <a:ext cx="2926080" cy="502920"/>
           </a:xfrm>
           <a:prstGeom prst="roundRect">
@@ -25894,7 +25975,7 @@
         </p:nvSpPr>
         <p:spPr>
           <a:xfrm>
-            <a:off x="6812280" y="4974336"/>
+            <a:off x="6812280" y="4919472"/>
             <a:ext cx="2926080" cy="502920"/>
           </a:xfrm>
           <a:prstGeom prst="rect">
@@ -25933,12 +26014,12 @@
         </p:nvSpPr>
         <p:spPr>
           <a:xfrm>
-            <a:off x="502920" y="5650992"/>
-            <a:ext cx="11155680" cy="658368"/>
+            <a:off x="502920" y="5596128"/>
+            <a:ext cx="11155680" cy="914400"/>
           </a:xfrm>
           <a:prstGeom prst="roundRect">
             <a:avLst>
-              <a:gd name="adj" fmla="val 13889"/>
+              <a:gd name="adj" fmla="val 10000"/>
             </a:avLst>
           </a:prstGeom>
           <a:solidFill>
@@ -25955,8 +26036,89 @@
         </p:nvSpPr>
         <p:spPr>
           <a:xfrm>
-            <a:off x="777240" y="5650992"/>
-            <a:ext cx="10607040" cy="658368"/>
+            <a:off x="777240" y="6071616"/>
+            <a:ext cx="10607040" cy="310896"/>
+          </a:xfrm>
+          <a:prstGeom prst="rect">
+            <a:avLst/>
+          </a:prstGeom>
+          <a:noFill/>
+          <a:ln/>
+        </p:spPr>
+        <p:txBody>
+          <a:bodyPr wrap="square" lIns="0" tIns="0" rIns="0" bIns="0" rtlCol="0" anchor="ctr"/>
+          <a:lstStyle/>
+          <a:p>
+            <a:pPr indent="0" marL="0">
+              <a:buNone/>
+            </a:pPr>
+            <a:r>
+              <a:rPr lang="en-US" sz="1000" b="1" spc="150" kern="0" dirty="0">
+                <a:solidFill>
+                  <a:srgbClr val="8FD7B8"/>
+                </a:solidFill>
+                <a:latin typeface="Calibri" pitchFamily="34" charset="0"/>
+                <a:ea typeface="Calibri" pitchFamily="34" charset="-122"/>
+                <a:cs typeface="Calibri" pitchFamily="34" charset="-120"/>
+              </a:rPr>
+              <a:t>SIGN IN  </a:t>
+            </a:r>
+            <a:pPr indent="0" marL="0">
+              <a:buNone/>
+            </a:pPr>
+            <a:r>
+              <a:rPr lang="en-US" sz="1150" dirty="0">
+                <a:solidFill>
+                  <a:srgbClr val="C9D4DD"/>
+                </a:solidFill>
+                <a:latin typeface="Calibri" pitchFamily="34" charset="0"/>
+                <a:ea typeface="Calibri" pitchFamily="34" charset="-122"/>
+                <a:cs typeface="Calibri" pitchFamily="34" charset="-120"/>
+              </a:rPr>
+              <a:t>underwriter / demo-underwriter-pw</a:t>
+            </a:r>
+            <a:pPr indent="0" marL="0">
+              <a:buNone/>
+            </a:pPr>
+            <a:r>
+              <a:rPr lang="en-US" sz="1150" dirty="0">
+                <a:solidFill>
+                  <a:srgbClr val="5A6E7C"/>
+                </a:solidFill>
+                <a:latin typeface="Calibri" pitchFamily="34" charset="0"/>
+                <a:ea typeface="Calibri" pitchFamily="34" charset="-122"/>
+                <a:cs typeface="Calibri" pitchFamily="34" charset="-120"/>
+              </a:rPr>
+              <a:t>   ·   </a:t>
+            </a:r>
+            <a:pPr indent="0" marL="0">
+              <a:buNone/>
+            </a:pPr>
+            <a:r>
+              <a:rPr lang="en-US" sz="1150" dirty="0">
+                <a:solidFill>
+                  <a:srgbClr val="C9D4DD"/>
+                </a:solidFill>
+                <a:latin typeface="Calibri" pitchFamily="34" charset="0"/>
+                <a:ea typeface="Calibri" pitchFamily="34" charset="-122"/>
+                <a:cs typeface="Calibri" pitchFamily="34" charset="-120"/>
+              </a:rPr>
+              <a:t>applicant / demo-applicant-pw</a:t>
+            </a:r>
+            <a:endParaRPr lang="en-US" sz="1000" dirty="0"/>
+          </a:p>
+        </p:txBody>
+      </p:sp>
+      <p:sp>
+        <p:nvSpPr>
+          <p:cNvPr id="27" name="Text 25"/>
+          <p:cNvSpPr txBox="1"/>
+          <p:nvPr/>
+        </p:nvSpPr>
+        <p:spPr>
+          <a:xfrm>
+            <a:off x="777240" y="5687568"/>
+            <a:ext cx="10607040" cy="384048"/>
           </a:xfrm>
           <a:prstGeom prst="rect">
             <a:avLst/>

</xml_diff>